<commit_message>
Phase 9 - Task 6: System Refinement, Testing & Deployment
</commit_message>
<xml_diff>
--- a/NeighborHub_April18_Deliverables.pptx
+++ b/NeighborHub_April18_Deliverables.pptx
@@ -310,7 +310,7 @@
           <a:p>
             <a:fld id="{5BCAD085-E8A6-8845-BD4E-CB4CCA059FC4}" type="datetimeFigureOut">
               <a:rPr lang="en-US" smtClean="0"/>
-              <a:t>4/17/2026</a:t>
+              <a:t>4/23/2026</a:t>
             </a:fld>
             <a:endParaRPr lang="en-US"/>
           </a:p>
@@ -478,7 +478,7 @@
           <a:p>
             <a:fld id="{5BCAD085-E8A6-8845-BD4E-CB4CCA059FC4}" type="datetimeFigureOut">
               <a:rPr lang="en-US" smtClean="0"/>
-              <a:t>4/17/2026</a:t>
+              <a:t>4/23/2026</a:t>
             </a:fld>
             <a:endParaRPr lang="en-US"/>
           </a:p>
@@ -656,7 +656,7 @@
           <a:p>
             <a:fld id="{5BCAD085-E8A6-8845-BD4E-CB4CCA059FC4}" type="datetimeFigureOut">
               <a:rPr lang="en-US" smtClean="0"/>
-              <a:t>4/17/2026</a:t>
+              <a:t>4/23/2026</a:t>
             </a:fld>
             <a:endParaRPr lang="en-US"/>
           </a:p>
@@ -824,7 +824,7 @@
           <a:p>
             <a:fld id="{5BCAD085-E8A6-8845-BD4E-CB4CCA059FC4}" type="datetimeFigureOut">
               <a:rPr lang="en-US" smtClean="0"/>
-              <a:t>4/17/2026</a:t>
+              <a:t>4/23/2026</a:t>
             </a:fld>
             <a:endParaRPr lang="en-US"/>
           </a:p>
@@ -1069,7 +1069,7 @@
           <a:p>
             <a:fld id="{5BCAD085-E8A6-8845-BD4E-CB4CCA059FC4}" type="datetimeFigureOut">
               <a:rPr lang="en-US" smtClean="0"/>
-              <a:t>4/17/2026</a:t>
+              <a:t>4/23/2026</a:t>
             </a:fld>
             <a:endParaRPr lang="en-US"/>
           </a:p>
@@ -1354,7 +1354,7 @@
           <a:p>
             <a:fld id="{5BCAD085-E8A6-8845-BD4E-CB4CCA059FC4}" type="datetimeFigureOut">
               <a:rPr lang="en-US" smtClean="0"/>
-              <a:t>4/17/2026</a:t>
+              <a:t>4/23/2026</a:t>
             </a:fld>
             <a:endParaRPr lang="en-US"/>
           </a:p>
@@ -1773,7 +1773,7 @@
           <a:p>
             <a:fld id="{5BCAD085-E8A6-8845-BD4E-CB4CCA059FC4}" type="datetimeFigureOut">
               <a:rPr lang="en-US" smtClean="0"/>
-              <a:t>4/17/2026</a:t>
+              <a:t>4/23/2026</a:t>
             </a:fld>
             <a:endParaRPr lang="en-US"/>
           </a:p>
@@ -1890,7 +1890,7 @@
           <a:p>
             <a:fld id="{5BCAD085-E8A6-8845-BD4E-CB4CCA059FC4}" type="datetimeFigureOut">
               <a:rPr lang="en-US" smtClean="0"/>
-              <a:t>4/17/2026</a:t>
+              <a:t>4/23/2026</a:t>
             </a:fld>
             <a:endParaRPr lang="en-US"/>
           </a:p>
@@ -1985,7 +1985,7 @@
           <a:p>
             <a:fld id="{5BCAD085-E8A6-8845-BD4E-CB4CCA059FC4}" type="datetimeFigureOut">
               <a:rPr lang="en-US" smtClean="0"/>
-              <a:t>4/17/2026</a:t>
+              <a:t>4/23/2026</a:t>
             </a:fld>
             <a:endParaRPr lang="en-US"/>
           </a:p>
@@ -2260,7 +2260,7 @@
           <a:p>
             <a:fld id="{5BCAD085-E8A6-8845-BD4E-CB4CCA059FC4}" type="datetimeFigureOut">
               <a:rPr lang="en-US" smtClean="0"/>
-              <a:t>4/17/2026</a:t>
+              <a:t>4/23/2026</a:t>
             </a:fld>
             <a:endParaRPr lang="en-US"/>
           </a:p>
@@ -2512,7 +2512,7 @@
           <a:p>
             <a:fld id="{5BCAD085-E8A6-8845-BD4E-CB4CCA059FC4}" type="datetimeFigureOut">
               <a:rPr lang="en-US" smtClean="0"/>
-              <a:t>4/17/2026</a:t>
+              <a:t>4/23/2026</a:t>
             </a:fld>
             <a:endParaRPr lang="en-US"/>
           </a:p>
@@ -2723,7 +2723,7 @@
           <a:p>
             <a:fld id="{5BCAD085-E8A6-8845-BD4E-CB4CCA059FC4}" type="datetimeFigureOut">
               <a:rPr lang="en-US" smtClean="0"/>
-              <a:t>4/17/2026</a:t>
+              <a:t>4/23/2026</a:t>
             </a:fld>
             <a:endParaRPr lang="en-US"/>
           </a:p>
@@ -4792,7 +4792,7 @@
               </a:spcBef>
             </a:pPr>
             <a:r>
-              <a:rPr sz="1150">
+              <a:rPr sz="1150" dirty="0">
                 <a:solidFill>
                   <a:srgbClr val="1F2937"/>
                 </a:solidFill>
@@ -4807,7 +4807,7 @@
               </a:spcBef>
             </a:pPr>
             <a:r>
-              <a:rPr sz="1150">
+              <a:rPr sz="1150" dirty="0">
                 <a:solidFill>
                   <a:srgbClr val="1F2937"/>
                 </a:solidFill>
@@ -4822,7 +4822,7 @@
               </a:spcBef>
             </a:pPr>
             <a:r>
-              <a:rPr sz="1150">
+              <a:rPr sz="1150" dirty="0">
                 <a:solidFill>
                   <a:srgbClr val="1F2937"/>
                 </a:solidFill>
@@ -4836,7 +4836,7 @@
                 <a:spcPts val="300"/>
               </a:spcBef>
             </a:pPr>
-            <a:endParaRPr sz="1150">
+            <a:endParaRPr sz="1150" dirty="0">
               <a:solidFill>
                 <a:srgbClr val="1F2937"/>
               </a:solidFill>
@@ -4849,7 +4849,7 @@
               </a:spcBef>
             </a:pPr>
             <a:r>
-              <a:rPr sz="1150">
+              <a:rPr sz="1150" dirty="0">
                 <a:solidFill>
                   <a:srgbClr val="1F2937"/>
                 </a:solidFill>
@@ -4864,7 +4864,7 @@
               </a:spcBef>
             </a:pPr>
             <a:r>
-              <a:rPr sz="1150">
+              <a:rPr sz="1150" dirty="0">
                 <a:solidFill>
                   <a:srgbClr val="1F2937"/>
                 </a:solidFill>
@@ -4878,7 +4878,7 @@
                 <a:spcPts val="300"/>
               </a:spcBef>
             </a:pPr>
-            <a:endParaRPr sz="1150">
+            <a:endParaRPr sz="1150" dirty="0">
               <a:solidFill>
                 <a:srgbClr val="1F2937"/>
               </a:solidFill>
@@ -4891,22 +4891,38 @@
               </a:spcBef>
             </a:pPr>
             <a:r>
-              <a:rPr sz="1150">
-                <a:solidFill>
-                  <a:srgbClr val="1F2937"/>
-                </a:solidFill>
-              </a:rPr>
-              <a:t>Backend: POST /api/auth/login</a:t>
-            </a:r>
-          </a:p>
-          <a:p>
-            <a:pPr>
-              <a:spcBef>
-                <a:spcPts val="300"/>
-              </a:spcBef>
-            </a:pPr>
-            <a:r>
-              <a:rPr sz="1150">
+              <a:rPr sz="1150" dirty="0">
+                <a:solidFill>
+                  <a:srgbClr val="1F2937"/>
+                </a:solidFill>
+              </a:rPr>
+              <a:t>Backend: POST /</a:t>
+            </a:r>
+            <a:r>
+              <a:rPr sz="1150" dirty="0" err="1">
+                <a:solidFill>
+                  <a:srgbClr val="1F2937"/>
+                </a:solidFill>
+              </a:rPr>
+              <a:t>api</a:t>
+            </a:r>
+            <a:r>
+              <a:rPr sz="1150" dirty="0">
+                <a:solidFill>
+                  <a:srgbClr val="1F2937"/>
+                </a:solidFill>
+              </a:rPr>
+              <a:t>/auth/login</a:t>
+            </a:r>
+          </a:p>
+          <a:p>
+            <a:pPr>
+              <a:spcBef>
+                <a:spcPts val="300"/>
+              </a:spcBef>
+            </a:pPr>
+            <a:r>
+              <a:rPr sz="1150" dirty="0">
                 <a:solidFill>
                   <a:srgbClr val="1F2937"/>
                 </a:solidFill>
@@ -4921,22 +4937,38 @@
               </a:spcBef>
             </a:pPr>
             <a:r>
-              <a:rPr sz="1150">
-                <a:solidFill>
-                  <a:srgbClr val="1F2937"/>
-                </a:solidFill>
-              </a:rPr>
-              <a:t>  BCrypt.compare() password check</a:t>
-            </a:r>
-          </a:p>
-          <a:p>
-            <a:pPr>
-              <a:spcBef>
-                <a:spcPts val="300"/>
-              </a:spcBef>
-            </a:pPr>
-            <a:r>
-              <a:rPr sz="1150">
+              <a:rPr sz="1150" dirty="0">
+                <a:solidFill>
+                  <a:srgbClr val="1F2937"/>
+                </a:solidFill>
+              </a:rPr>
+              <a:t>  </a:t>
+            </a:r>
+            <a:r>
+              <a:rPr sz="1150" dirty="0" err="1">
+                <a:solidFill>
+                  <a:srgbClr val="1F2937"/>
+                </a:solidFill>
+              </a:rPr>
+              <a:t>BCrypt.compare</a:t>
+            </a:r>
+            <a:r>
+              <a:rPr sz="1150" dirty="0">
+                <a:solidFill>
+                  <a:srgbClr val="1F2937"/>
+                </a:solidFill>
+              </a:rPr>
+              <a:t>() password check</a:t>
+            </a:r>
+          </a:p>
+          <a:p>
+            <a:pPr>
+              <a:spcBef>
+                <a:spcPts val="300"/>
+              </a:spcBef>
+            </a:pPr>
+            <a:r>
+              <a:rPr sz="1150" dirty="0">
                 <a:solidFill>
                   <a:srgbClr val="1F2937"/>
                 </a:solidFill>
@@ -4951,7 +4983,7 @@
               </a:spcBef>
             </a:pPr>
             <a:r>
-              <a:rPr sz="1150">
+              <a:rPr sz="1150" dirty="0">
                 <a:solidFill>
                   <a:srgbClr val="1F2937"/>
                 </a:solidFill>
@@ -4965,7 +4997,7 @@
                 <a:spcPts val="300"/>
               </a:spcBef>
             </a:pPr>
-            <a:endParaRPr sz="1150">
+            <a:endParaRPr sz="1150" dirty="0">
               <a:solidFill>
                 <a:srgbClr val="1F2937"/>
               </a:solidFill>
@@ -4978,7 +5010,7 @@
               </a:spcBef>
             </a:pPr>
             <a:r>
-              <a:rPr sz="1150">
+              <a:rPr sz="1150" dirty="0">
                 <a:solidFill>
                   <a:srgbClr val="1F2937"/>
                 </a:solidFill>
@@ -4993,7 +5025,7 @@
               </a:spcBef>
             </a:pPr>
             <a:r>
-              <a:rPr sz="1150">
+              <a:rPr sz="1150" dirty="0">
                 <a:solidFill>
                   <a:srgbClr val="1F2937"/>
                 </a:solidFill>
@@ -5008,7 +5040,7 @@
               </a:spcBef>
             </a:pPr>
             <a:r>
-              <a:rPr sz="1150">
+              <a:rPr sz="1150" dirty="0">
                 <a:solidFill>
                   <a:srgbClr val="1F2937"/>
                 </a:solidFill>
@@ -5022,7 +5054,7 @@
                 <a:spcPts val="300"/>
               </a:spcBef>
             </a:pPr>
-            <a:endParaRPr sz="1150">
+            <a:endParaRPr sz="1150" dirty="0">
               <a:solidFill>
                 <a:srgbClr val="1F2937"/>
               </a:solidFill>
@@ -5035,13 +5067,42 @@
               </a:spcBef>
             </a:pPr>
             <a:r>
-              <a:rPr sz="1150">
-                <a:solidFill>
-                  <a:srgbClr val="1F2937"/>
-                </a:solidFill>
-              </a:rPr>
-              <a:t>File: src/pages/Login.jsx</a:t>
-            </a:r>
+              <a:rPr sz="1150" dirty="0">
+                <a:solidFill>
+                  <a:srgbClr val="1F2937"/>
+                </a:solidFill>
+              </a:rPr>
+              <a:t>File: </a:t>
+            </a:r>
+            <a:r>
+              <a:rPr sz="1150" dirty="0" err="1">
+                <a:solidFill>
+                  <a:srgbClr val="1F2937"/>
+                </a:solidFill>
+              </a:rPr>
+              <a:t>src</a:t>
+            </a:r>
+            <a:r>
+              <a:rPr sz="1150" dirty="0">
+                <a:solidFill>
+                  <a:srgbClr val="1F2937"/>
+                </a:solidFill>
+              </a:rPr>
+              <a:t>/pages/</a:t>
+            </a:r>
+            <a:r>
+              <a:rPr sz="1150" dirty="0" err="1">
+                <a:solidFill>
+                  <a:srgbClr val="1F2937"/>
+                </a:solidFill>
+              </a:rPr>
+              <a:t>Login.jsx</a:t>
+            </a:r>
+            <a:endParaRPr sz="1150" dirty="0">
+              <a:solidFill>
+                <a:srgbClr val="1F2937"/>
+              </a:solidFill>
+            </a:endParaRPr>
           </a:p>
         </p:txBody>
       </p:sp>

</xml_diff>